<commit_message>
added Lecture 12, 10-15-26
</commit_message>
<xml_diff>
--- a/lecture_slides/Week6_Lecture12_STFT_Spectrograms_101326_forClass.pptx
+++ b/lecture_slides/Week6_Lecture12_STFT_Spectrograms_101326_forClass.pptx
@@ -22,7 +22,8 @@
     <p:sldId id="269" r:id="rId16"/>
     <p:sldId id="270" r:id="rId17"/>
     <p:sldId id="271" r:id="rId18"/>
-    <p:sldId id="272" r:id="rId19"/>
+    <p:sldId id="297" r:id="rId19"/>
+    <p:sldId id="272" r:id="rId20"/>
   </p:sldIdLst>
   <p:sldSz cx="12192000" cy="6858000"/>
   <p:notesSz cx="6858000" cy="9144000"/>
@@ -319,7 +320,7 @@
           <a:p>
             <a:fld id="{5BCAD085-E8A6-8845-BD4E-CB4CCA059FC4}" type="datetimeFigureOut">
               <a:rPr lang="en-US" smtClean="0"/>
-              <a:t>10/12/2026</a:t>
+              <a:t>10/15/2026</a:t>
             </a:fld>
             <a:endParaRPr lang="en-US"/>
           </a:p>
@@ -487,7 +488,7 @@
           <a:p>
             <a:fld id="{5BCAD085-E8A6-8845-BD4E-CB4CCA059FC4}" type="datetimeFigureOut">
               <a:rPr lang="en-US" smtClean="0"/>
-              <a:t>10/12/2026</a:t>
+              <a:t>10/15/2026</a:t>
             </a:fld>
             <a:endParaRPr lang="en-US"/>
           </a:p>
@@ -665,7 +666,7 @@
           <a:p>
             <a:fld id="{5BCAD085-E8A6-8845-BD4E-CB4CCA059FC4}" type="datetimeFigureOut">
               <a:rPr lang="en-US" smtClean="0"/>
-              <a:t>10/12/2026</a:t>
+              <a:t>10/15/2026</a:t>
             </a:fld>
             <a:endParaRPr lang="en-US"/>
           </a:p>
@@ -833,7 +834,7 @@
           <a:p>
             <a:fld id="{5BCAD085-E8A6-8845-BD4E-CB4CCA059FC4}" type="datetimeFigureOut">
               <a:rPr lang="en-US" smtClean="0"/>
-              <a:t>10/12/2026</a:t>
+              <a:t>10/15/2026</a:t>
             </a:fld>
             <a:endParaRPr lang="en-US"/>
           </a:p>
@@ -1078,7 +1079,7 @@
           <a:p>
             <a:fld id="{5BCAD085-E8A6-8845-BD4E-CB4CCA059FC4}" type="datetimeFigureOut">
               <a:rPr lang="en-US" smtClean="0"/>
-              <a:t>10/12/2026</a:t>
+              <a:t>10/15/2026</a:t>
             </a:fld>
             <a:endParaRPr lang="en-US"/>
           </a:p>
@@ -1363,7 +1364,7 @@
           <a:p>
             <a:fld id="{5BCAD085-E8A6-8845-BD4E-CB4CCA059FC4}" type="datetimeFigureOut">
               <a:rPr lang="en-US" smtClean="0"/>
-              <a:t>10/12/2026</a:t>
+              <a:t>10/15/2026</a:t>
             </a:fld>
             <a:endParaRPr lang="en-US"/>
           </a:p>
@@ -1782,7 +1783,7 @@
           <a:p>
             <a:fld id="{5BCAD085-E8A6-8845-BD4E-CB4CCA059FC4}" type="datetimeFigureOut">
               <a:rPr lang="en-US" smtClean="0"/>
-              <a:t>10/12/2026</a:t>
+              <a:t>10/15/2026</a:t>
             </a:fld>
             <a:endParaRPr lang="en-US"/>
           </a:p>
@@ -1899,7 +1900,7 @@
           <a:p>
             <a:fld id="{5BCAD085-E8A6-8845-BD4E-CB4CCA059FC4}" type="datetimeFigureOut">
               <a:rPr lang="en-US" smtClean="0"/>
-              <a:t>10/12/2026</a:t>
+              <a:t>10/15/2026</a:t>
             </a:fld>
             <a:endParaRPr lang="en-US"/>
           </a:p>
@@ -1994,7 +1995,7 @@
           <a:p>
             <a:fld id="{5BCAD085-E8A6-8845-BD4E-CB4CCA059FC4}" type="datetimeFigureOut">
               <a:rPr lang="en-US" smtClean="0"/>
-              <a:t>10/12/2026</a:t>
+              <a:t>10/15/2026</a:t>
             </a:fld>
             <a:endParaRPr lang="en-US"/>
           </a:p>
@@ -2269,7 +2270,7 @@
           <a:p>
             <a:fld id="{5BCAD085-E8A6-8845-BD4E-CB4CCA059FC4}" type="datetimeFigureOut">
               <a:rPr lang="en-US" smtClean="0"/>
-              <a:t>10/12/2026</a:t>
+              <a:t>10/15/2026</a:t>
             </a:fld>
             <a:endParaRPr lang="en-US"/>
           </a:p>
@@ -2521,7 +2522,7 @@
           <a:p>
             <a:fld id="{5BCAD085-E8A6-8845-BD4E-CB4CCA059FC4}" type="datetimeFigureOut">
               <a:rPr lang="en-US" smtClean="0"/>
-              <a:t>10/12/2026</a:t>
+              <a:t>10/15/2026</a:t>
             </a:fld>
             <a:endParaRPr lang="en-US"/>
           </a:p>
@@ -2732,7 +2733,7 @@
           <a:p>
             <a:fld id="{5BCAD085-E8A6-8845-BD4E-CB4CCA059FC4}" type="datetimeFigureOut">
               <a:rPr lang="en-US" smtClean="0"/>
-              <a:t>10/12/2026</a:t>
+              <a:t>10/15/2026</a:t>
             </a:fld>
             <a:endParaRPr lang="en-US"/>
           </a:p>
@@ -6666,6 +6667,126 @@
 </file>
 
 <file path=ppt/slides/slide18.xml><?xml version="1.0" encoding="utf-8"?>
+<p:sld xmlns:a="http://schemas.openxmlformats.org/drawingml/2006/main" xmlns:r="http://schemas.openxmlformats.org/officeDocument/2006/relationships" xmlns:p="http://schemas.openxmlformats.org/presentationml/2006/main">
+  <p:cSld>
+    <p:spTree>
+      <p:nvGrpSpPr>
+        <p:cNvPr id="1" name=""/>
+        <p:cNvGrpSpPr/>
+        <p:nvPr/>
+      </p:nvGrpSpPr>
+      <p:grpSpPr>
+        <a:xfrm>
+          <a:off x="0" y="0"/>
+          <a:ext cx="0" cy="0"/>
+          <a:chOff x="0" y="0"/>
+          <a:chExt cx="0" cy="0"/>
+        </a:xfrm>
+      </p:grpSpPr>
+      <p:pic>
+        <p:nvPicPr>
+          <p:cNvPr id="4" name="Picture 3" descr="The image displays a Python code snippet demonstrating how to create a spectrogram tensor from an audio signal, apply a Short-Time Fourier Transform (STFT), and pass it through a simple Convolutional Neural Network (CNN) to obtain logits.&#10;&#10;AI-generated content may be incorrect.">
+            <a:extLst>
+              <a:ext uri="{FF2B5EF4-FFF2-40B4-BE49-F238E27FC236}">
+                <a16:creationId xmlns:a16="http://schemas.microsoft.com/office/drawing/2014/main" id="{DFE06033-F347-1EE7-8EB3-84D12EFB0E90}"/>
+              </a:ext>
+            </a:extLst>
+          </p:cNvPr>
+          <p:cNvPicPr>
+            <a:picLocks noChangeAspect="1"/>
+          </p:cNvPicPr>
+          <p:nvPr/>
+        </p:nvPicPr>
+        <p:blipFill>
+          <a:blip r:embed="rId2"/>
+          <a:stretch>
+            <a:fillRect/>
+          </a:stretch>
+        </p:blipFill>
+        <p:spPr>
+          <a:xfrm>
+            <a:off x="364170" y="275228"/>
+            <a:ext cx="7229475" cy="4151668"/>
+          </a:xfrm>
+          <a:prstGeom prst="rect">
+            <a:avLst/>
+          </a:prstGeom>
+        </p:spPr>
+      </p:pic>
+      <p:pic>
+        <p:nvPicPr>
+          <p:cNvPr id="2" name="Picture 1" descr="convnet">
+            <a:extLst>
+              <a:ext uri="{FF2B5EF4-FFF2-40B4-BE49-F238E27FC236}">
+                <a16:creationId xmlns:a16="http://schemas.microsoft.com/office/drawing/2014/main" id="{6FDFAD07-769E-51D5-E604-8D3F90744D78}"/>
+              </a:ext>
+            </a:extLst>
+          </p:cNvPr>
+          <p:cNvPicPr>
+            <a:picLocks noChangeAspect="1"/>
+          </p:cNvPicPr>
+          <p:nvPr/>
+        </p:nvPicPr>
+        <p:blipFill>
+          <a:blip r:embed="rId3"/>
+          <a:stretch>
+            <a:fillRect/>
+          </a:stretch>
+        </p:blipFill>
+        <p:spPr>
+          <a:xfrm>
+            <a:off x="4511195" y="4381881"/>
+            <a:ext cx="7229475" cy="1990725"/>
+          </a:xfrm>
+          <a:prstGeom prst="rect">
+            <a:avLst/>
+          </a:prstGeom>
+        </p:spPr>
+      </p:pic>
+      <p:pic>
+        <p:nvPicPr>
+          <p:cNvPr id="6" name="Picture 5" descr="shape&#10;&#10;AI-generated content may be incorrect.">
+            <a:extLst>
+              <a:ext uri="{FF2B5EF4-FFF2-40B4-BE49-F238E27FC236}">
+                <a16:creationId xmlns:a16="http://schemas.microsoft.com/office/drawing/2014/main" id="{422AB9FA-0410-F48F-9682-2E3840C705DD}"/>
+              </a:ext>
+            </a:extLst>
+          </p:cNvPr>
+          <p:cNvPicPr>
+            <a:picLocks noChangeAspect="1"/>
+          </p:cNvPicPr>
+          <p:nvPr/>
+        </p:nvPicPr>
+        <p:blipFill>
+          <a:blip r:embed="rId4"/>
+          <a:stretch>
+            <a:fillRect/>
+          </a:stretch>
+        </p:blipFill>
+        <p:spPr>
+          <a:xfrm>
+            <a:off x="8402831" y="735887"/>
+            <a:ext cx="842260" cy="710141"/>
+          </a:xfrm>
+          <a:prstGeom prst="rect">
+            <a:avLst/>
+          </a:prstGeom>
+        </p:spPr>
+      </p:pic>
+    </p:spTree>
+    <p:extLst>
+      <p:ext uri="{BB962C8B-B14F-4D97-AF65-F5344CB8AC3E}">
+        <p14:creationId xmlns:p14="http://schemas.microsoft.com/office/powerpoint/2010/main" val="3057415973"/>
+      </p:ext>
+    </p:extLst>
+  </p:cSld>
+  <p:clrMapOvr>
+    <a:masterClrMapping/>
+  </p:clrMapOvr>
+</p:sld>
+</file>
+
+<file path=ppt/slides/slide19.xml><?xml version="1.0" encoding="utf-8"?>
 <p:sld xmlns:a="http://schemas.openxmlformats.org/drawingml/2006/main" xmlns:r="http://schemas.openxmlformats.org/officeDocument/2006/relationships" xmlns:p="http://schemas.openxmlformats.org/presentationml/2006/main">
   <p:cSld>
     <p:bg>

</xml_diff>